<commit_message>
security: remove exposed API keys from tracked files, inject via .env and environment variables
</commit_message>
<xml_diff>
--- a/rag_module/results/proposals/AO-2026-TN-042_OliveSoft_Proposal.pptx
+++ b/rag_module/results/proposals/AO-2026-TN-042_OliveSoft_Proposal.pptx
@@ -3203,7 +3203,7 @@
               </a:defRPr>
             </a:pPr>
             <a:r>
-              <a:t>Mise en place d un systeme national d information hospitalier et dossiers medicaux partages</a:t>
+              <a:t>Mise en place d'un système national d'information hospitalier et dossiers médicaux partagés</a:t>
             </a:r>
           </a:p>
         </p:txBody>
@@ -3330,7 +3330,7 @@
               </a:defRPr>
             </a:pPr>
             <a:r>
-              <a:t>14 Semaines</a:t>
+              <a:t>18 Semaines</a:t>
             </a:r>
           </a:p>
           <a:p>
@@ -3434,7 +3434,7 @@
               </a:defRPr>
             </a:pPr>
             <a:r>
-              <a:t>77,224.00 TND HT</a:t>
+              <a:t>99,512.00 TND HT</a:t>
             </a:r>
           </a:p>
           <a:p>
@@ -3538,7 +3538,7 @@
               </a:defRPr>
             </a:pPr>
             <a:r>
-              <a:t>92% Fit Score</a:t>
+              <a:t>100% Fit Score</a:t>
             </a:r>
           </a:p>
           <a:p>
@@ -5221,7 +5221,7 @@
               </a:defRPr>
             </a:pPr>
             <a:r>
-              <a:t>PHASE 1 (2 SEM.)</a:t>
+              <a:t>PHASE 1 (3 SEM.)</a:t>
             </a:r>
           </a:p>
           <a:p>
@@ -5481,7 +5481,7 @@
               </a:defRPr>
             </a:pPr>
             <a:r>
-              <a:t>PHASE 2 (6 SEM.)</a:t>
+              <a:t>PHASE 2 (8 SEM.)</a:t>
             </a:r>
           </a:p>
           <a:p>
@@ -5741,7 +5741,7 @@
               </a:defRPr>
             </a:pPr>
             <a:r>
-              <a:t>PHASE 3 (3 SEM.)</a:t>
+              <a:t>PHASE 3 (4 SEM.)</a:t>
             </a:r>
           </a:p>
           <a:p>
@@ -6817,7 +6817,7 @@
                         </a:defRPr>
                       </a:pPr>
                       <a:r>
-                        <a:t>Semaines 1 à 2</a:t>
+                        <a:t>Semaines 1 à 3</a:t>
                       </a:r>
                     </a:p>
                   </a:txBody>
@@ -6911,7 +6911,7 @@
                         </a:defRPr>
                       </a:pPr>
                       <a:r>
-                        <a:t>Semaines 3 à 8</a:t>
+                        <a:t>Semaines 4 à 11</a:t>
                       </a:r>
                     </a:p>
                   </a:txBody>
@@ -7005,7 +7005,7 @@
                         </a:defRPr>
                       </a:pPr>
                       <a:r>
-                        <a:t>Semaines 9 à 11</a:t>
+                        <a:t>Semaines 12 à 15</a:t>
                       </a:r>
                     </a:p>
                   </a:txBody>
@@ -7099,7 +7099,7 @@
                         </a:defRPr>
                       </a:pPr>
                       <a:r>
-                        <a:t>Semaines 12 à 13</a:t>
+                        <a:t>Semaines 16 à 17</a:t>
                       </a:r>
                     </a:p>
                   </a:txBody>
@@ -7193,7 +7193,7 @@
                         </a:defRPr>
                       </a:pPr>
                       <a:r>
-                        <a:t>Semaines 14 à 14</a:t>
+                        <a:t>Semaines 18 à 18</a:t>
                       </a:r>
                     </a:p>
                   </a:txBody>
@@ -7667,7 +7667,7 @@
               </a:defRPr>
             </a:pPr>
             <a:r>
-              <a:t>Mohamed Kacem</a:t>
+              <a:t>Leila Nasr</a:t>
             </a:r>
           </a:p>
           <a:p>
@@ -7682,7 +7682,7 @@
               </a:defRPr>
             </a:pPr>
             <a:r>
-              <a:t>Directeur Technique &amp; Architecte</a:t>
+              <a:t>Information Security Analyst</a:t>
             </a:r>
           </a:p>
           <a:p>
@@ -7697,7 +7697,7 @@
               </a:defRPr>
             </a:pPr>
             <a:r>
-              <a:t>Titre : Lead Solutions Architect</a:t>
+              <a:t>Titre : Information Security Analyst</a:t>
             </a:r>
           </a:p>
           <a:p>
@@ -7709,7 +7709,7 @@
               </a:defRPr>
             </a:pPr>
             <a:r>
-              <a:t>Référence CV : CV-003 (Certifié OliveSoft)</a:t>
+              <a:t>Référence CV : CV-021 (Certifié OliveSoft)</a:t>
             </a:r>
           </a:p>
           <a:p>
@@ -7727,450 +7727,11 @@
               <a:t>Compétences clés validées :</a:t>
             </a:r>
           </a:p>
-          <a:p>
-            <a:pPr>
-              <a:spcBef>
-                <a:spcPts val="300"/>
-              </a:spcBef>
-              <a:defRPr sz="950">
-                <a:solidFill>
-                  <a:srgbClr val="1E293B"/>
-                </a:solidFill>
-              </a:defRPr>
-            </a:pPr>
-            <a:r>
-              <a:t>• Spring Boot</a:t>
-            </a:r>
-          </a:p>
-          <a:p>
-            <a:pPr>
-              <a:spcBef>
-                <a:spcPts val="300"/>
-              </a:spcBef>
-              <a:defRPr sz="950">
-                <a:solidFill>
-                  <a:srgbClr val="1E293B"/>
-                </a:solidFill>
-              </a:defRPr>
-            </a:pPr>
-            <a:r>
-              <a:t>• Microservices</a:t>
-            </a:r>
-          </a:p>
-          <a:p>
-            <a:pPr>
-              <a:spcBef>
-                <a:spcPts val="300"/>
-              </a:spcBef>
-              <a:defRPr sz="950">
-                <a:solidFill>
-                  <a:srgbClr val="1E293B"/>
-                </a:solidFill>
-              </a:defRPr>
-            </a:pPr>
-            <a:r>
-              <a:t>• Kubernetes</a:t>
-            </a:r>
-          </a:p>
-        </p:txBody>
-      </p:sp>
-      <p:sp>
-        <p:nvSpPr>
-          <p:cNvPr id="8" name="Rounded Rectangle 7"/>
-          <p:cNvSpPr/>
-          <p:nvPr/>
-        </p:nvSpPr>
-        <p:spPr>
-          <a:xfrm>
-            <a:off x="4389120" y="1325880"/>
-            <a:ext cx="3291840" cy="4846320"/>
-          </a:xfrm>
-          <a:prstGeom prst="roundRect">
-            <a:avLst/>
-          </a:prstGeom>
-          <a:solidFill>
-            <a:srgbClr val="F8FAFC"/>
-          </a:solidFill>
-          <a:ln>
-            <a:solidFill>
-              <a:srgbClr val="3B6E4C"/>
-            </a:solidFill>
-          </a:ln>
-        </p:spPr>
-        <p:style>
-          <a:lnRef idx="1">
-            <a:schemeClr val="accent1"/>
-          </a:lnRef>
-          <a:fillRef idx="3">
-            <a:schemeClr val="accent1"/>
-          </a:fillRef>
-          <a:effectRef idx="2">
-            <a:schemeClr val="accent1"/>
-          </a:effectRef>
-          <a:fontRef idx="minor">
-            <a:schemeClr val="lt1"/>
-          </a:fontRef>
-        </p:style>
-        <p:txBody>
-          <a:bodyPr rtlCol="0" anchor="ctr"/>
-          <a:lstStyle/>
-          <a:p>
-            <a:pPr algn="ctr"/>
-          </a:p>
-        </p:txBody>
-      </p:sp>
-      <p:sp>
-        <p:nvSpPr>
-          <p:cNvPr id="9" name="TextBox 8"/>
-          <p:cNvSpPr txBox="1"/>
-          <p:nvPr/>
-        </p:nvSpPr>
-        <p:spPr>
-          <a:xfrm>
-            <a:off x="4572000" y="1508760"/>
-            <a:ext cx="2926080" cy="4480560"/>
-          </a:xfrm>
-          <a:prstGeom prst="rect">
-            <a:avLst/>
-          </a:prstGeom>
-          <a:noFill/>
-        </p:spPr>
-        <p:txBody>
-          <a:bodyPr wrap="square">
-            <a:spAutoFit/>
-          </a:bodyPr>
-          <a:lstStyle/>
-          <a:p>
-            <a:pPr>
-              <a:defRPr sz="1700" b="1">
-                <a:solidFill>
-                  <a:srgbClr val="26462B"/>
-                </a:solidFill>
-              </a:defRPr>
-            </a:pPr>
-            <a:r>
-              <a:t>Ahmed Ben Ali</a:t>
-            </a:r>
-          </a:p>
-          <a:p>
-            <a:pPr>
-              <a:spcBef>
-                <a:spcPts val="400"/>
-              </a:spcBef>
-              <a:defRPr sz="1100" b="1">
-                <a:solidFill>
-                  <a:srgbClr val="D97706"/>
-                </a:solidFill>
-              </a:defRPr>
-            </a:pPr>
-            <a:r>
-              <a:t>Tech Lead Développement</a:t>
-            </a:r>
-          </a:p>
-          <a:p>
-            <a:pPr>
-              <a:spcBef>
-                <a:spcPts val="800"/>
-              </a:spcBef>
-              <a:defRPr sz="1000">
-                <a:solidFill>
-                  <a:srgbClr val="64748B"/>
-                </a:solidFill>
-              </a:defRPr>
-            </a:pPr>
-            <a:r>
-              <a:t>Titre : Senior Full-Stack Engineer</a:t>
-            </a:r>
-          </a:p>
-          <a:p>
-            <a:pPr>
-              <a:defRPr sz="950">
-                <a:solidFill>
-                  <a:srgbClr val="64748B"/>
-                </a:solidFill>
-              </a:defRPr>
-            </a:pPr>
-            <a:r>
-              <a:t>Référence CV : CV-001 (Certifié OliveSoft)</a:t>
-            </a:r>
-          </a:p>
-          <a:p>
-            <a:pPr>
-              <a:spcBef>
-                <a:spcPts val="1400"/>
-              </a:spcBef>
-              <a:defRPr sz="1100" b="1">
-                <a:solidFill>
-                  <a:srgbClr val="0F172A"/>
-                </a:solidFill>
-              </a:defRPr>
-            </a:pPr>
-            <a:r>
-              <a:t>Compétences clés validées :</a:t>
-            </a:r>
-          </a:p>
-          <a:p>
-            <a:pPr>
-              <a:spcBef>
-                <a:spcPts val="300"/>
-              </a:spcBef>
-              <a:defRPr sz="950">
-                <a:solidFill>
-                  <a:srgbClr val="1E293B"/>
-                </a:solidFill>
-              </a:defRPr>
-            </a:pPr>
-            <a:r>
-              <a:t>• React</a:t>
-            </a:r>
-          </a:p>
-          <a:p>
-            <a:pPr>
-              <a:spcBef>
-                <a:spcPts val="300"/>
-              </a:spcBef>
-              <a:defRPr sz="950">
-                <a:solidFill>
-                  <a:srgbClr val="1E293B"/>
-                </a:solidFill>
-              </a:defRPr>
-            </a:pPr>
-            <a:r>
-              <a:t>• Java</a:t>
-            </a:r>
-          </a:p>
-          <a:p>
-            <a:pPr>
-              <a:spcBef>
-                <a:spcPts val="300"/>
-              </a:spcBef>
-              <a:defRPr sz="950">
-                <a:solidFill>
-                  <a:srgbClr val="1E293B"/>
-                </a:solidFill>
-              </a:defRPr>
-            </a:pPr>
-            <a:r>
-              <a:t>• Docker</a:t>
-            </a:r>
-          </a:p>
-          <a:p>
-            <a:pPr>
-              <a:spcBef>
-                <a:spcPts val="300"/>
-              </a:spcBef>
-              <a:defRPr sz="950">
-                <a:solidFill>
-                  <a:srgbClr val="1E293B"/>
-                </a:solidFill>
-              </a:defRPr>
-            </a:pPr>
-            <a:r>
-              <a:t>• PostgreSQL</a:t>
-            </a:r>
-          </a:p>
-        </p:txBody>
-      </p:sp>
-      <p:sp>
-        <p:nvSpPr>
-          <p:cNvPr id="10" name="Rounded Rectangle 9"/>
-          <p:cNvSpPr/>
-          <p:nvPr/>
-        </p:nvSpPr>
-        <p:spPr>
-          <a:xfrm>
-            <a:off x="7955279" y="1325880"/>
-            <a:ext cx="3291840" cy="4846320"/>
-          </a:xfrm>
-          <a:prstGeom prst="roundRect">
-            <a:avLst/>
-          </a:prstGeom>
-          <a:solidFill>
-            <a:srgbClr val="F8FAFC"/>
-          </a:solidFill>
-          <a:ln>
-            <a:solidFill>
-              <a:srgbClr val="3B6E4C"/>
-            </a:solidFill>
-          </a:ln>
-        </p:spPr>
-        <p:style>
-          <a:lnRef idx="1">
-            <a:schemeClr val="accent1"/>
-          </a:lnRef>
-          <a:fillRef idx="3">
-            <a:schemeClr val="accent1"/>
-          </a:fillRef>
-          <a:effectRef idx="2">
-            <a:schemeClr val="accent1"/>
-          </a:effectRef>
-          <a:fontRef idx="minor">
-            <a:schemeClr val="lt1"/>
-          </a:fontRef>
-        </p:style>
-        <p:txBody>
-          <a:bodyPr rtlCol="0" anchor="ctr"/>
-          <a:lstStyle/>
-          <a:p>
-            <a:pPr algn="ctr"/>
-          </a:p>
-        </p:txBody>
-      </p:sp>
-      <p:sp>
-        <p:nvSpPr>
-          <p:cNvPr id="11" name="TextBox 10"/>
-          <p:cNvSpPr txBox="1"/>
-          <p:nvPr/>
-        </p:nvSpPr>
-        <p:spPr>
-          <a:xfrm>
-            <a:off x="8138159" y="1508760"/>
-            <a:ext cx="2926080" cy="4480560"/>
-          </a:xfrm>
-          <a:prstGeom prst="rect">
-            <a:avLst/>
-          </a:prstGeom>
-          <a:noFill/>
-        </p:spPr>
-        <p:txBody>
-          <a:bodyPr wrap="square">
-            <a:spAutoFit/>
-          </a:bodyPr>
-          <a:lstStyle/>
-          <a:p>
-            <a:pPr>
-              <a:defRPr sz="1700" b="1">
-                <a:solidFill>
-                  <a:srgbClr val="26462B"/>
-                </a:solidFill>
-              </a:defRPr>
-            </a:pPr>
-            <a:r>
-              <a:t>Karim Mansour</a:t>
-            </a:r>
-          </a:p>
-          <a:p>
-            <a:pPr>
-              <a:spcBef>
-                <a:spcPts val="400"/>
-              </a:spcBef>
-              <a:defRPr sz="1100" b="1">
-                <a:solidFill>
-                  <a:srgbClr val="D97706"/>
-                </a:solidFill>
-              </a:defRPr>
-            </a:pPr>
-            <a:r>
-              <a:t>Responsable Infrastructure &amp; Déploiement</a:t>
-            </a:r>
-          </a:p>
-          <a:p>
-            <a:pPr>
-              <a:spcBef>
-                <a:spcPts val="800"/>
-              </a:spcBef>
-              <a:defRPr sz="1000">
-                <a:solidFill>
-                  <a:srgbClr val="64748B"/>
-                </a:solidFill>
-              </a:defRPr>
-            </a:pPr>
-            <a:r>
-              <a:t>Titre : Cloud &amp; DevOps Engineer</a:t>
-            </a:r>
-          </a:p>
-          <a:p>
-            <a:pPr>
-              <a:defRPr sz="950">
-                <a:solidFill>
-                  <a:srgbClr val="64748B"/>
-                </a:solidFill>
-              </a:defRPr>
-            </a:pPr>
-            <a:r>
-              <a:t>Référence CV : CV-008 (Certifié OliveSoft)</a:t>
-            </a:r>
-          </a:p>
-          <a:p>
-            <a:pPr>
-              <a:spcBef>
-                <a:spcPts val="1400"/>
-              </a:spcBef>
-              <a:defRPr sz="1100" b="1">
-                <a:solidFill>
-                  <a:srgbClr val="0F172A"/>
-                </a:solidFill>
-              </a:defRPr>
-            </a:pPr>
-            <a:r>
-              <a:t>Compétences clés validées :</a:t>
-            </a:r>
-          </a:p>
-          <a:p>
-            <a:pPr>
-              <a:spcBef>
-                <a:spcPts val="300"/>
-              </a:spcBef>
-              <a:defRPr sz="950">
-                <a:solidFill>
-                  <a:srgbClr val="1E293B"/>
-                </a:solidFill>
-              </a:defRPr>
-            </a:pPr>
-            <a:r>
-              <a:t>• CI/CD</a:t>
-            </a:r>
-          </a:p>
-          <a:p>
-            <a:pPr>
-              <a:spcBef>
-                <a:spcPts val="300"/>
-              </a:spcBef>
-              <a:defRPr sz="950">
-                <a:solidFill>
-                  <a:srgbClr val="1E293B"/>
-                </a:solidFill>
-              </a:defRPr>
-            </a:pPr>
-            <a:r>
-              <a:t>• Docker</a:t>
-            </a:r>
-          </a:p>
-          <a:p>
-            <a:pPr>
-              <a:spcBef>
-                <a:spcPts val="300"/>
-              </a:spcBef>
-              <a:defRPr sz="950">
-                <a:solidFill>
-                  <a:srgbClr val="1E293B"/>
-                </a:solidFill>
-              </a:defRPr>
-            </a:pPr>
-            <a:r>
-              <a:t>• Kubernetes</a:t>
-            </a:r>
-          </a:p>
-          <a:p>
-            <a:pPr>
-              <a:spcBef>
-                <a:spcPts val="300"/>
-              </a:spcBef>
-              <a:defRPr sz="950">
-                <a:solidFill>
-                  <a:srgbClr val="1E293B"/>
-                </a:solidFill>
-              </a:defRPr>
-            </a:pPr>
-            <a:r>
-              <a:t>• Linux</a:t>
-            </a:r>
-          </a:p>
-        </p:txBody>
-      </p:sp>
-      <p:sp>
-        <p:nvSpPr>
-          <p:cNvPr id="12" name="TextBox 11"/>
+        </p:txBody>
+      </p:sp>
+      <p:sp>
+        <p:nvSpPr>
+          <p:cNvPr id="8" name="TextBox 7"/>
           <p:cNvSpPr txBox="1"/>
           <p:nvPr/>
         </p:nvSpPr>
@@ -8205,7 +7766,7 @@
       </p:sp>
       <p:sp>
         <p:nvSpPr>
-          <p:cNvPr id="13" name="TextBox 12"/>
+          <p:cNvPr id="9" name="TextBox 8"/>
           <p:cNvSpPr txBox="1"/>
           <p:nvPr/>
         </p:nvSpPr>
@@ -8582,7 +8143,7 @@
                         </a:defRPr>
                       </a:pPr>
                       <a:r>
-                        <a:t>16 j/h</a:t>
+                        <a:t>20 j/h</a:t>
                       </a:r>
                     </a:p>
                   </a:txBody>
@@ -8605,7 +8166,7 @@
                         </a:defRPr>
                       </a:pPr>
                       <a:r>
-                        <a:t>13,600.00 TND</a:t>
+                        <a:t>17,000.00 TND</a:t>
                       </a:r>
                     </a:p>
                   </a:txBody>
@@ -8676,7 +8237,7 @@
                         </a:defRPr>
                       </a:pPr>
                       <a:r>
-                        <a:t>48 j/h</a:t>
+                        <a:t>62 j/h</a:t>
                       </a:r>
                     </a:p>
                   </a:txBody>
@@ -8699,7 +8260,7 @@
                         </a:defRPr>
                       </a:pPr>
                       <a:r>
-                        <a:t>31,200.00 TND</a:t>
+                        <a:t>40,300.00 TND</a:t>
                       </a:r>
                     </a:p>
                   </a:txBody>
@@ -8770,7 +8331,7 @@
                         </a:defRPr>
                       </a:pPr>
                       <a:r>
-                        <a:t>14 j/h</a:t>
+                        <a:t>18 j/h</a:t>
                       </a:r>
                     </a:p>
                   </a:txBody>
@@ -8793,7 +8354,7 @@
                         </a:defRPr>
                       </a:pPr>
                       <a:r>
-                        <a:t>9,800.00 TND</a:t>
+                        <a:t>12,600.00 TND</a:t>
                       </a:r>
                     </a:p>
                   </a:txBody>
@@ -8864,7 +8425,7 @@
                         </a:defRPr>
                       </a:pPr>
                       <a:r>
-                        <a:t>13 j/h</a:t>
+                        <a:t>17 j/h</a:t>
                       </a:r>
                     </a:p>
                   </a:txBody>
@@ -8887,7 +8448,7 @@
                         </a:defRPr>
                       </a:pPr>
                       <a:r>
-                        <a:t>7,150.00 TND</a:t>
+                        <a:t>9,350.00 TND</a:t>
                       </a:r>
                     </a:p>
                   </a:txBody>
@@ -8958,7 +8519,7 @@
                         </a:defRPr>
                       </a:pPr>
                       <a:r>
-                        <a:t>12 j/h</a:t>
+                        <a:t>16 j/h</a:t>
                       </a:r>
                     </a:p>
                   </a:txBody>
@@ -8981,7 +8542,7 @@
                         </a:defRPr>
                       </a:pPr>
                       <a:r>
-                        <a:t>7,200.00 TND</a:t>
+                        <a:t>9,600.00 TND</a:t>
                       </a:r>
                     </a:p>
                   </a:txBody>
@@ -9033,7 +8594,7 @@
                         <a:defRPr b="1"/>
                       </a:pPr>
                       <a:r>
-                        <a:t>68,950.00 TND</a:t>
+                        <a:t>88,850.00 TND</a:t>
                       </a:r>
                     </a:p>
                   </a:txBody>
@@ -9075,7 +8636,7 @@
                     <a:lstStyle/>
                     <a:p>
                       <a:r>
-                        <a:t>8,274.00 TND</a:t>
+                        <a:t>10,662.00 TND</a:t>
                       </a:r>
                     </a:p>
                   </a:txBody>
@@ -9143,7 +8704,7 @@
                         </a:defRPr>
                       </a:pPr>
                       <a:r>
-                        <a:t>77,224.00 TND</a:t>
+                        <a:t>99,512.00 TND</a:t>
                       </a:r>
                     </a:p>
                   </a:txBody>
@@ -9259,7 +8820,7 @@
             </a:r>
             <a:br/>
             <a:r>
-              <a:t>  11,583.60 TND HT / an (Support N2/N3, correctifs de sécurité, astreinte 4h).</a:t>
+              <a:t>  14,926.80 TND HT / an (Support N2/N3, correctifs de sécurité, astreinte 4h).</a:t>
             </a:r>
           </a:p>
           <a:p>

</xml_diff>